<commit_message>
feat(website): Drucksachen auf der Beispielseite und News-Artikel dazu
Abschnitt „Auch auf Papier“ mit Bewerbung, Urkunde, Einladung, Speisekarte und Visitenkarte, echt
gerendert über scripts/folien.mjs; alle Folienbilder neu vom aktuellen Stand. Neuigkeit
„Bewerbung, Visitenkarte, Speisekarte: Drucksachen mit Deckwerk“.

Co-Authored-By: Claude Opus 5.5 <noreply@anthropic.com>
</commit_message>
<xml_diff>
--- a/website/public/beispiele/deckwerk.pptx
+++ b/website/public/beispiele/deckwerk.pptx
@@ -127,7 +127,7 @@
   <p:extLst>
     <p:ext uri="{521415D9-36F7-43E2-AB2F-B90AF26B5E84}">
       <p14:sectionLst xmlns:p14="http://schemas.microsoft.com/office/powerpoint/2010/main">
-        <p14:section name="Einstieg" id="{CAE1EF8B-70C6-4C00-A259-3B61B4A4C7FD}">
+        <p14:section name="Einstieg" id="{E0B1692A-57AC-44DA-ABAE-69D209A40C08}">
           <p14:sldIdLst>
             <p14:sldId id="256"/>
             <p14:sldId id="257"/>
@@ -136,7 +136,7 @@
             <p14:sldId id="260"/>
           </p14:sldIdLst>
         </p14:section>
-        <p14:section name="Geprüft, bevor du es siehst" id="{A5739CE2-FCBE-4ACB-8069-863722414C1E}">
+        <p14:section name="Geprüft, bevor du es siehst" id="{9FDE56C4-E4C8-486E-A4EF-136DF41670EC}">
           <p14:sldIdLst>
             <p14:sldId id="261"/>
             <p14:sldId id="262"/>
@@ -1898,7 +1898,7 @@
       </p:grpSpPr>
       <p:pic>
         <p:nvPicPr>
-          <p:cNvPr id="2" name="dw:image" descr="/tmp/dw-folien-Hiwzgf/assets/arbeitsplatz.jpg">    </p:cNvPr>
+          <p:cNvPr id="2" name="dw:image" descr=" ">    </p:cNvPr>
           <p:cNvPicPr>
             <a:picLocks noChangeAspect="1"/>
           </p:cNvPicPr>
@@ -1940,14 +1940,24 @@
                   <a:alpha val="90000"/>
                 </a:srgbClr>
               </a:gs>
-              <a:gs pos="55000">
+              <a:gs pos="50000">
                 <a:srgbClr val="000004">
                   <a:alpha val="80000"/>
                 </a:srgbClr>
               </a:gs>
+              <a:gs pos="80000">
+                <a:srgbClr val="000004">
+                  <a:alpha val="62000"/>
+                </a:srgbClr>
+              </a:gs>
+              <a:gs pos="90000">
+                <a:srgbClr val="000004">
+                  <a:alpha val="40000"/>
+                </a:srgbClr>
+              </a:gs>
               <a:gs pos="100000">
                 <a:srgbClr val="000004">
-                  <a:alpha val="25000"/>
+                  <a:alpha val="15000"/>
                 </a:srgbClr>
               </a:gs>
             </a:gsLst>
@@ -2205,7 +2215,7 @@
       </p:grpSpPr>
       <p:pic>
         <p:nvPicPr>
-          <p:cNvPr id="2" name="dw:image" descr="/tmp/dw-folien-Hiwzgf/assets/schreibtisch.jpg">    </p:cNvPr>
+          <p:cNvPr id="2" name="dw:image" descr=" ">    </p:cNvPr>
           <p:cNvPicPr>
             <a:picLocks noChangeAspect="1"/>
           </p:cNvPicPr>
@@ -2247,14 +2257,24 @@
                   <a:alpha val="90000"/>
                 </a:srgbClr>
               </a:gs>
-              <a:gs pos="55000">
+              <a:gs pos="50000">
                 <a:srgbClr val="000004">
                   <a:alpha val="80000"/>
                 </a:srgbClr>
               </a:gs>
+              <a:gs pos="80000">
+                <a:srgbClr val="000004">
+                  <a:alpha val="62000"/>
+                </a:srgbClr>
+              </a:gs>
+              <a:gs pos="90000">
+                <a:srgbClr val="000004">
+                  <a:alpha val="40000"/>
+                </a:srgbClr>
+              </a:gs>
               <a:gs pos="100000">
                 <a:srgbClr val="000004">
-                  <a:alpha val="25000"/>
+                  <a:alpha val="15000"/>
                 </a:srgbClr>
               </a:gs>
             </a:gsLst>
@@ -2575,90 +2595,6 @@
           </a:p>
         </p:txBody>
       </p:sp>
-      <p:sp>
-        <p:nvSpPr>
-          <p:cNvPr id="5" name="dw:_footer.title"/>
-          <p:cNvSpPr/>
-          <p:nvPr/>
-        </p:nvSpPr>
-        <p:spPr>
-          <a:xfrm>
-            <a:off x="685800" y="6450360"/>
-            <a:ext cx="617007" cy="148530"/>
-          </a:xfrm>
-          <a:prstGeom prst="rect">
-            <a:avLst/>
-          </a:prstGeom>
-          <a:noFill/>
-          <a:ln/>
-        </p:spPr>
-        <p:txBody>
-          <a:bodyPr wrap="square" lIns="0" tIns="0" rIns="0" bIns="0" rtlCol="0" anchor="t"/>
-          <a:lstStyle/>
-          <a:p>
-            <a:pPr algn="l" indent="0" marL="0">
-              <a:lnSpc>
-                <a:spcPts val="1170"/>
-              </a:lnSpc>
-              <a:buNone/>
-            </a:pPr>
-            <a:r>
-              <a:rPr lang="de-DE" altLang="en-US" sz="975" spc="20" kern="0" dirty="0">
-                <a:solidFill>
-                  <a:srgbClr val="575964"/>
-                </a:solidFill>
-                <a:latin typeface="Inter" pitchFamily="34" charset="0"/>
-                <a:ea typeface="Inter" pitchFamily="34" charset="-122"/>
-                <a:cs typeface="Inter" pitchFamily="34" charset="-120"/>
-              </a:rPr>
-              <a:t>Deckwerk</a:t>
-            </a:r>
-            <a:endParaRPr lang="de-DE" sz="975" dirty="0"/>
-          </a:p>
-        </p:txBody>
-      </p:sp>
-      <p:sp>
-        <p:nvSpPr>
-          <p:cNvPr id="6" name="dw:_footer.page"/>
-          <p:cNvSpPr/>
-          <p:nvPr/>
-        </p:nvSpPr>
-        <p:spPr>
-          <a:xfrm>
-            <a:off x="11400458" y="6450360"/>
-            <a:ext cx="107329" cy="148530"/>
-          </a:xfrm>
-          <a:prstGeom prst="rect">
-            <a:avLst/>
-          </a:prstGeom>
-          <a:noFill/>
-          <a:ln/>
-        </p:spPr>
-        <p:txBody>
-          <a:bodyPr wrap="square" lIns="0" tIns="0" rIns="0" bIns="0" rtlCol="0" anchor="t"/>
-          <a:lstStyle/>
-          <a:p>
-            <a:pPr algn="l" indent="0" marL="0">
-              <a:lnSpc>
-                <a:spcPts val="1170"/>
-              </a:lnSpc>
-              <a:buNone/>
-            </a:pPr>
-            <a:r>
-              <a:rPr lang="de-DE" altLang="en-US" sz="975" spc="20" kern="0" dirty="0">
-                <a:solidFill>
-                  <a:srgbClr val="575964"/>
-                </a:solidFill>
-                <a:latin typeface="Inter" pitchFamily="34" charset="0"/>
-                <a:ea typeface="Inter" pitchFamily="34" charset="-122"/>
-                <a:cs typeface="Inter" pitchFamily="34" charset="-120"/>
-              </a:rPr>
-              <a:t>11</a:t>
-            </a:r>
-            <a:endParaRPr lang="de-DE" sz="975" dirty="0"/>
-          </a:p>
-        </p:txBody>
-      </p:sp>
     </p:spTree>
   </p:cSld>
   <p:clrMapOvr>
@@ -3002,7 +2938,7 @@
       </p:grpSpPr>
       <p:pic>
         <p:nvPicPr>
-          <p:cNvPr id="2" name="dw:image" descr="/tmp/dw-folien-Hiwzgf/assets/laptop-gast.jpg">    </p:cNvPr>
+          <p:cNvPr id="2" name="dw:image" descr=" ">    </p:cNvPr>
           <p:cNvPicPr>
             <a:picLocks noChangeAspect="1"/>
           </p:cNvPicPr>
@@ -3044,14 +2980,24 @@
                   <a:alpha val="90000"/>
                 </a:srgbClr>
               </a:gs>
-              <a:gs pos="55000">
+              <a:gs pos="50000">
                 <a:srgbClr val="000004">
                   <a:alpha val="80000"/>
                 </a:srgbClr>
               </a:gs>
+              <a:gs pos="80000">
+                <a:srgbClr val="000004">
+                  <a:alpha val="62000"/>
+                </a:srgbClr>
+              </a:gs>
+              <a:gs pos="90000">
+                <a:srgbClr val="000004">
+                  <a:alpha val="40000"/>
+                </a:srgbClr>
+              </a:gs>
               <a:gs pos="100000">
                 <a:srgbClr val="000004">
-                  <a:alpha val="25000"/>
+                  <a:alpha val="15000"/>
                 </a:srgbClr>
               </a:gs>
             </a:gsLst>
@@ -3342,7 +3288,7 @@
         </p:nvSpPr>
         <p:spPr>
           <a:xfrm>
-            <a:off x="1068705" y="2360861"/>
+            <a:off x="685800" y="2360861"/>
             <a:ext cx="10054590" cy="2021904"/>
           </a:xfrm>
           <a:prstGeom prst="rect">
@@ -3355,7 +3301,7 @@
           <a:bodyPr wrap="square" lIns="0" tIns="0" rIns="0" bIns="0" rtlCol="0" anchor="t"/>
           <a:lstStyle/>
           <a:p>
-            <a:pPr algn="ctr" indent="0" marL="0">
+            <a:pPr algn="l" indent="0" marL="0">
               <a:lnSpc>
                 <a:spcPts val="5307"/>
               </a:lnSpc>
@@ -3375,7 +3321,7 @@
             <a:endParaRPr lang="de-DE" sz="4575" dirty="0"/>
           </a:p>
           <a:p>
-            <a:pPr algn="ctr" indent="0" marL="0">
+            <a:pPr algn="l" indent="0" marL="0">
               <a:lnSpc>
                 <a:spcPts val="5307"/>
               </a:lnSpc>
@@ -3392,7 +3338,7 @@
               </a:rPr>
               <a:t>Kästchen</a:t>
             </a:r>
-            <a:pPr algn="ctr" indent="0" marL="0">
+            <a:pPr algn="l" indent="0" marL="0">
               <a:lnSpc>
                 <a:spcPts val="5307"/>
               </a:lnSpc>
@@ -3412,7 +3358,7 @@
             <a:endParaRPr lang="de-DE" sz="4575" dirty="0"/>
           </a:p>
           <a:p>
-            <a:pPr algn="ctr" indent="0" marL="0">
+            <a:pPr algn="l" indent="0" marL="0">
               <a:lnSpc>
                 <a:spcPts val="5307"/>
               </a:lnSpc>
@@ -3635,7 +3581,7 @@
         <p:spPr>
           <a:xfrm>
             <a:off x="685800" y="2065288"/>
-            <a:ext cx="2419350" cy="2077120"/>
+            <a:ext cx="2505075" cy="2384227"/>
           </a:xfrm>
           <a:prstGeom prst="rect">
             <a:avLst/>
@@ -3645,31 +3591,14 @@
       </p:sp>
       <p:sp>
         <p:nvSpPr>
-          <p:cNvPr id="4" name="dw:_badge.0"/>
+          <p:cNvPr id="4" name="dw:_n.0"/>
           <p:cNvSpPr/>
           <p:nvPr/>
         </p:nvSpPr>
         <p:spPr>
           <a:xfrm>
             <a:off x="685800" y="2331988"/>
-            <a:ext cx="78060" cy="180975"/>
-          </a:xfrm>
-          <a:prstGeom prst="ellipse">
-            <a:avLst/>
-          </a:prstGeom>
-          <a:ln/>
-        </p:spPr>
-      </p:sp>
-      <p:sp>
-        <p:nvSpPr>
-          <p:cNvPr id="5" name="dw:_n.0"/>
-          <p:cNvSpPr/>
-          <p:nvPr/>
-        </p:nvSpPr>
-        <p:spPr>
-          <a:xfrm>
-            <a:off x="685800" y="2331988"/>
-            <a:ext cx="79231" cy="180975"/>
+            <a:ext cx="618668" cy="488082"/>
           </a:xfrm>
           <a:prstGeom prst="rect">
             <a:avLst/>
@@ -3683,12 +3612,12 @@
           <a:p>
             <a:pPr algn="l" indent="0" marL="0">
               <a:lnSpc>
-                <a:spcPts val="1425"/>
+                <a:spcPts val="3843"/>
               </a:lnSpc>
               <a:buNone/>
             </a:pPr>
             <a:r>
-              <a:rPr lang="de-DE" altLang="en-US" sz="1425" b="1" dirty="0">
+              <a:rPr lang="de-DE" altLang="en-US" sz="3843" b="1" spc="-85" kern="0" dirty="0">
                 <a:solidFill>
                   <a:srgbClr val="4F52D9"/>
                 </a:solidFill>
@@ -3696,22 +3625,22 @@
                 <a:ea typeface="Inter" pitchFamily="34" charset="-122"/>
                 <a:cs typeface="Inter" pitchFamily="34" charset="-120"/>
               </a:rPr>
-              <a:t>1</a:t>
+              <a:t>01</a:t>
             </a:r>
-            <a:endParaRPr lang="de-DE" sz="1425" dirty="0"/>
+            <a:endParaRPr lang="de-DE" sz="3843" dirty="0"/>
           </a:p>
         </p:txBody>
       </p:sp>
       <p:sp>
         <p:nvSpPr>
-          <p:cNvPr id="6" name="dw:steps.0.title"/>
+          <p:cNvPr id="5" name="dw:steps.0.title"/>
           <p:cNvSpPr/>
           <p:nvPr/>
         </p:nvSpPr>
         <p:spPr>
           <a:xfrm>
-            <a:off x="685800" y="2722513"/>
-            <a:ext cx="2339626" cy="302121"/>
+            <a:off x="685800" y="3029620"/>
+            <a:ext cx="2426637" cy="302121"/>
           </a:xfrm>
           <a:prstGeom prst="rect">
             <a:avLst/>
@@ -3746,14 +3675,14 @@
       </p:sp>
       <p:sp>
         <p:nvSpPr>
-          <p:cNvPr id="7" name="dw:steps.0.desc"/>
+          <p:cNvPr id="6" name="dw:steps.0.desc"/>
           <p:cNvSpPr/>
           <p:nvPr/>
         </p:nvSpPr>
         <p:spPr>
           <a:xfrm>
-            <a:off x="685800" y="3157984"/>
-            <a:ext cx="2339626" cy="630882"/>
+            <a:off x="685800" y="3465091"/>
+            <a:ext cx="2426637" cy="630882"/>
           </a:xfrm>
           <a:prstGeom prst="rect">
             <a:avLst/>
@@ -3786,40 +3715,16 @@
           </a:p>
         </p:txBody>
       </p:sp>
-      <p:pic>
-        <p:nvPicPr>
-          <p:cNvPr id="8" name="dw:_arrow.1" descr="preencoded.png">    </p:cNvPr>
-          <p:cNvPicPr>
-            <a:picLocks noChangeAspect="1"/>
-          </p:cNvPicPr>
+      <p:sp>
+        <p:nvSpPr>
+          <p:cNvPr id="7" name="dw:_card.1"/>
+          <p:cNvSpPr/>
           <p:nvPr/>
-        </p:nvPicPr>
-        <p:blipFill>
-          <a:blip r:embed="rId2"/>
-          <a:stretch>
-            <a:fillRect/>
-          </a:stretch>
-        </p:blipFill>
+        </p:nvSpPr>
         <p:spPr>
           <a:xfrm>
-            <a:off x="3171825" y="2979986"/>
-            <a:ext cx="247650" cy="247650"/>
-          </a:xfrm>
-          <a:prstGeom prst="rect">
-            <a:avLst/>
-          </a:prstGeom>
-        </p:spPr>
-      </p:pic>
-      <p:sp>
-        <p:nvSpPr>
-          <p:cNvPr id="9" name="dw:_card.1"/>
-          <p:cNvSpPr/>
-          <p:nvPr/>
-        </p:nvSpPr>
-        <p:spPr>
-          <a:xfrm>
-            <a:off x="3486150" y="2065288"/>
-            <a:ext cx="2419350" cy="2077120"/>
+            <a:off x="3457575" y="2065288"/>
+            <a:ext cx="2505075" cy="2384227"/>
           </a:xfrm>
           <a:prstGeom prst="rect">
             <a:avLst/>
@@ -3829,31 +3734,14 @@
       </p:sp>
       <p:sp>
         <p:nvSpPr>
-          <p:cNvPr id="10" name="dw:_badge.1"/>
+          <p:cNvPr id="8" name="dw:_n.1"/>
           <p:cNvSpPr/>
           <p:nvPr/>
         </p:nvSpPr>
         <p:spPr>
           <a:xfrm>
-            <a:off x="3486150" y="2331988"/>
-            <a:ext cx="114002" cy="180975"/>
-          </a:xfrm>
-          <a:prstGeom prst="ellipse">
-            <a:avLst/>
-          </a:prstGeom>
-          <a:ln/>
-        </p:spPr>
-      </p:sp>
-      <p:sp>
-        <p:nvSpPr>
-          <p:cNvPr id="11" name="dw:_n.1"/>
-          <p:cNvSpPr/>
-          <p:nvPr/>
-        </p:nvSpPr>
-        <p:spPr>
-          <a:xfrm>
-            <a:off x="3486150" y="2331988"/>
-            <a:ext cx="115712" cy="180975"/>
+            <a:off x="3457575" y="2331988"/>
+            <a:ext cx="618668" cy="488082"/>
           </a:xfrm>
           <a:prstGeom prst="rect">
             <a:avLst/>
@@ -3867,12 +3755,12 @@
           <a:p>
             <a:pPr algn="l" indent="0" marL="0">
               <a:lnSpc>
-                <a:spcPts val="1425"/>
+                <a:spcPts val="3843"/>
               </a:lnSpc>
               <a:buNone/>
             </a:pPr>
             <a:r>
-              <a:rPr lang="de-DE" altLang="en-US" sz="1425" b="1" dirty="0">
+              <a:rPr lang="de-DE" altLang="en-US" sz="3843" b="1" spc="-85" kern="0" dirty="0">
                 <a:solidFill>
                   <a:srgbClr val="4F52D9"/>
                 </a:solidFill>
@@ -3880,22 +3768,22 @@
                 <a:ea typeface="Inter" pitchFamily="34" charset="-122"/>
                 <a:cs typeface="Inter" pitchFamily="34" charset="-120"/>
               </a:rPr>
-              <a:t>2</a:t>
+              <a:t>02</a:t>
             </a:r>
-            <a:endParaRPr lang="de-DE" sz="1425" dirty="0"/>
+            <a:endParaRPr lang="de-DE" sz="3843" dirty="0"/>
           </a:p>
         </p:txBody>
       </p:sp>
       <p:sp>
         <p:nvSpPr>
-          <p:cNvPr id="12" name="dw:steps.1.title"/>
+          <p:cNvPr id="9" name="dw:steps.1.title"/>
           <p:cNvSpPr/>
           <p:nvPr/>
         </p:nvSpPr>
         <p:spPr>
           <a:xfrm>
-            <a:off x="3486150" y="2722513"/>
-            <a:ext cx="2339626" cy="302121"/>
+            <a:off x="3457575" y="3029620"/>
+            <a:ext cx="2426637" cy="302121"/>
           </a:xfrm>
           <a:prstGeom prst="rect">
             <a:avLst/>
@@ -3930,14 +3818,14 @@
       </p:sp>
       <p:sp>
         <p:nvSpPr>
-          <p:cNvPr id="13" name="dw:steps.1.desc"/>
+          <p:cNvPr id="10" name="dw:steps.1.desc"/>
           <p:cNvSpPr/>
           <p:nvPr/>
         </p:nvSpPr>
         <p:spPr>
           <a:xfrm>
-            <a:off x="3486150" y="3157984"/>
-            <a:ext cx="2339626" cy="946324"/>
+            <a:off x="3457575" y="3465091"/>
+            <a:ext cx="2426637" cy="630882"/>
           </a:xfrm>
           <a:prstGeom prst="rect">
             <a:avLst/>
@@ -3970,40 +3858,16 @@
           </a:p>
         </p:txBody>
       </p:sp>
-      <p:pic>
-        <p:nvPicPr>
-          <p:cNvPr id="14" name="dw:_arrow.2" descr="preencoded.png">    </p:cNvPr>
-          <p:cNvPicPr>
-            <a:picLocks noChangeAspect="1"/>
-          </p:cNvPicPr>
+      <p:sp>
+        <p:nvSpPr>
+          <p:cNvPr id="11" name="dw:_card.2"/>
+          <p:cNvSpPr/>
           <p:nvPr/>
-        </p:nvPicPr>
-        <p:blipFill>
-          <a:blip r:embed="rId3"/>
-          <a:stretch>
-            <a:fillRect/>
-          </a:stretch>
-        </p:blipFill>
+        </p:nvSpPr>
         <p:spPr>
           <a:xfrm>
-            <a:off x="5972175" y="2979986"/>
-            <a:ext cx="247650" cy="247650"/>
-          </a:xfrm>
-          <a:prstGeom prst="rect">
-            <a:avLst/>
-          </a:prstGeom>
-        </p:spPr>
-      </p:pic>
-      <p:sp>
-        <p:nvSpPr>
-          <p:cNvPr id="15" name="dw:_card.2"/>
-          <p:cNvSpPr/>
-          <p:nvPr/>
-        </p:nvSpPr>
-        <p:spPr>
-          <a:xfrm>
-            <a:off x="6286500" y="2065288"/>
-            <a:ext cx="2419350" cy="2077120"/>
+            <a:off x="6229350" y="2065288"/>
+            <a:ext cx="2505075" cy="2384227"/>
           </a:xfrm>
           <a:prstGeom prst="rect">
             <a:avLst/>
@@ -4013,31 +3877,14 @@
       </p:sp>
       <p:sp>
         <p:nvSpPr>
-          <p:cNvPr id="16" name="dw:_badge.2"/>
+          <p:cNvPr id="12" name="dw:_n.2"/>
           <p:cNvSpPr/>
           <p:nvPr/>
         </p:nvSpPr>
         <p:spPr>
           <a:xfrm>
-            <a:off x="6286500" y="2331988"/>
-            <a:ext cx="116830" cy="180975"/>
-          </a:xfrm>
-          <a:prstGeom prst="ellipse">
-            <a:avLst/>
-          </a:prstGeom>
-          <a:ln/>
-        </p:spPr>
-      </p:sp>
-      <p:sp>
-        <p:nvSpPr>
-          <p:cNvPr id="17" name="dw:_n.2"/>
-          <p:cNvSpPr/>
-          <p:nvPr/>
-        </p:nvSpPr>
-        <p:spPr>
-          <a:xfrm>
-            <a:off x="6286500" y="2331988"/>
-            <a:ext cx="118583" cy="180975"/>
+            <a:off x="6229350" y="2331988"/>
+            <a:ext cx="618668" cy="488082"/>
           </a:xfrm>
           <a:prstGeom prst="rect">
             <a:avLst/>
@@ -4051,12 +3898,12 @@
           <a:p>
             <a:pPr algn="l" indent="0" marL="0">
               <a:lnSpc>
-                <a:spcPts val="1425"/>
+                <a:spcPts val="3843"/>
               </a:lnSpc>
               <a:buNone/>
             </a:pPr>
             <a:r>
-              <a:rPr lang="de-DE" altLang="en-US" sz="1425" b="1" dirty="0">
+              <a:rPr lang="de-DE" altLang="en-US" sz="3843" b="1" spc="-85" kern="0" dirty="0">
                 <a:solidFill>
                   <a:srgbClr val="4F52D9"/>
                 </a:solidFill>
@@ -4064,22 +3911,22 @@
                 <a:ea typeface="Inter" pitchFamily="34" charset="-122"/>
                 <a:cs typeface="Inter" pitchFamily="34" charset="-120"/>
               </a:rPr>
-              <a:t>3</a:t>
+              <a:t>03</a:t>
             </a:r>
-            <a:endParaRPr lang="de-DE" sz="1425" dirty="0"/>
+            <a:endParaRPr lang="de-DE" sz="3843" dirty="0"/>
           </a:p>
         </p:txBody>
       </p:sp>
       <p:sp>
         <p:nvSpPr>
-          <p:cNvPr id="18" name="dw:steps.2.title"/>
+          <p:cNvPr id="13" name="dw:steps.2.title"/>
           <p:cNvSpPr/>
           <p:nvPr/>
         </p:nvSpPr>
         <p:spPr>
           <a:xfrm>
-            <a:off x="6286500" y="2722513"/>
-            <a:ext cx="2339626" cy="302121"/>
+            <a:off x="6229350" y="3029620"/>
+            <a:ext cx="2426637" cy="302121"/>
           </a:xfrm>
           <a:prstGeom prst="rect">
             <a:avLst/>
@@ -4114,14 +3961,14 @@
       </p:sp>
       <p:sp>
         <p:nvSpPr>
-          <p:cNvPr id="19" name="dw:steps.2.desc"/>
+          <p:cNvPr id="14" name="dw:steps.2.desc"/>
           <p:cNvSpPr/>
           <p:nvPr/>
         </p:nvSpPr>
         <p:spPr>
           <a:xfrm>
-            <a:off x="6286500" y="3157984"/>
-            <a:ext cx="2339626" cy="946324"/>
+            <a:off x="6229350" y="3465091"/>
+            <a:ext cx="2426637" cy="946324"/>
           </a:xfrm>
           <a:prstGeom prst="rect">
             <a:avLst/>
@@ -4154,40 +4001,16 @@
           </a:p>
         </p:txBody>
       </p:sp>
-      <p:pic>
-        <p:nvPicPr>
-          <p:cNvPr id="20" name="dw:_arrow.3" descr="preencoded.png">    </p:cNvPr>
-          <p:cNvPicPr>
-            <a:picLocks noChangeAspect="1"/>
-          </p:cNvPicPr>
+      <p:sp>
+        <p:nvSpPr>
+          <p:cNvPr id="15" name="dw:_card.3"/>
+          <p:cNvSpPr/>
           <p:nvPr/>
-        </p:nvPicPr>
-        <p:blipFill>
-          <a:blip r:embed="rId4"/>
-          <a:stretch>
-            <a:fillRect/>
-          </a:stretch>
-        </p:blipFill>
+        </p:nvSpPr>
         <p:spPr>
           <a:xfrm>
-            <a:off x="8772525" y="2979986"/>
-            <a:ext cx="247650" cy="247650"/>
-          </a:xfrm>
-          <a:prstGeom prst="rect">
-            <a:avLst/>
-          </a:prstGeom>
-        </p:spPr>
-      </p:pic>
-      <p:sp>
-        <p:nvSpPr>
-          <p:cNvPr id="21" name="dw:_card.3"/>
-          <p:cNvSpPr/>
-          <p:nvPr/>
-        </p:nvSpPr>
-        <p:spPr>
-          <a:xfrm>
-            <a:off x="9086850" y="2065288"/>
-            <a:ext cx="2419350" cy="2077120"/>
+            <a:off x="9001125" y="2065288"/>
+            <a:ext cx="2505075" cy="2384227"/>
           </a:xfrm>
           <a:prstGeom prst="rect">
             <a:avLst/>
@@ -4197,31 +4020,14 @@
       </p:sp>
       <p:sp>
         <p:nvSpPr>
-          <p:cNvPr id="22" name="dw:_badge.3"/>
+          <p:cNvPr id="16" name="dw:_n.3"/>
           <p:cNvSpPr/>
           <p:nvPr/>
         </p:nvSpPr>
         <p:spPr>
           <a:xfrm>
-            <a:off x="9086850" y="2331988"/>
-            <a:ext cx="122411" cy="180975"/>
-          </a:xfrm>
-          <a:prstGeom prst="ellipse">
-            <a:avLst/>
-          </a:prstGeom>
-          <a:ln/>
-        </p:spPr>
-      </p:sp>
-      <p:sp>
-        <p:nvSpPr>
-          <p:cNvPr id="23" name="dw:_n.3"/>
-          <p:cNvSpPr/>
-          <p:nvPr/>
-        </p:nvSpPr>
-        <p:spPr>
-          <a:xfrm>
-            <a:off x="9086850" y="2331988"/>
-            <a:ext cx="124247" cy="180975"/>
+            <a:off x="9001125" y="2331988"/>
+            <a:ext cx="618668" cy="488082"/>
           </a:xfrm>
           <a:prstGeom prst="rect">
             <a:avLst/>
@@ -4235,12 +4041,12 @@
           <a:p>
             <a:pPr algn="l" indent="0" marL="0">
               <a:lnSpc>
-                <a:spcPts val="1425"/>
+                <a:spcPts val="3843"/>
               </a:lnSpc>
               <a:buNone/>
             </a:pPr>
             <a:r>
-              <a:rPr lang="de-DE" altLang="en-US" sz="1425" b="1" dirty="0">
+              <a:rPr lang="de-DE" altLang="en-US" sz="3843" b="1" spc="-85" kern="0" dirty="0">
                 <a:solidFill>
                   <a:srgbClr val="4F52D9"/>
                 </a:solidFill>
@@ -4248,22 +4054,22 @@
                 <a:ea typeface="Inter" pitchFamily="34" charset="-122"/>
                 <a:cs typeface="Inter" pitchFamily="34" charset="-120"/>
               </a:rPr>
-              <a:t>4</a:t>
+              <a:t>04</a:t>
             </a:r>
-            <a:endParaRPr lang="de-DE" sz="1425" dirty="0"/>
+            <a:endParaRPr lang="de-DE" sz="3843" dirty="0"/>
           </a:p>
         </p:txBody>
       </p:sp>
       <p:sp>
         <p:nvSpPr>
-          <p:cNvPr id="24" name="dw:steps.3.title"/>
+          <p:cNvPr id="17" name="dw:steps.3.title"/>
           <p:cNvSpPr/>
           <p:nvPr/>
         </p:nvSpPr>
         <p:spPr>
           <a:xfrm>
-            <a:off x="9086850" y="2722513"/>
-            <a:ext cx="2339626" cy="302121"/>
+            <a:off x="9001125" y="3029620"/>
+            <a:ext cx="2426637" cy="302121"/>
           </a:xfrm>
           <a:prstGeom prst="rect">
             <a:avLst/>
@@ -4298,14 +4104,14 @@
       </p:sp>
       <p:sp>
         <p:nvSpPr>
-          <p:cNvPr id="25" name="dw:steps.3.desc"/>
+          <p:cNvPr id="18" name="dw:steps.3.desc"/>
           <p:cNvSpPr/>
           <p:nvPr/>
         </p:nvSpPr>
         <p:spPr>
           <a:xfrm>
-            <a:off x="9086850" y="3157984"/>
-            <a:ext cx="2339626" cy="630882"/>
+            <a:off x="9001125" y="3465091"/>
+            <a:ext cx="2426637" cy="630882"/>
           </a:xfrm>
           <a:prstGeom prst="rect">
             <a:avLst/>
@@ -4340,14 +4146,14 @@
       </p:sp>
       <p:sp>
         <p:nvSpPr>
-          <p:cNvPr id="26" name="dw:_footer.title"/>
+          <p:cNvPr id="19" name="dw:_footer.page"/>
           <p:cNvSpPr/>
           <p:nvPr/>
         </p:nvSpPr>
         <p:spPr>
           <a:xfrm>
-            <a:off x="685800" y="6450360"/>
-            <a:ext cx="617007" cy="148530"/>
+            <a:off x="11174685" y="6450360"/>
+            <a:ext cx="336487" cy="148530"/>
           </a:xfrm>
           <a:prstGeom prst="rect">
             <a:avLst/>
@@ -4374,49 +4180,7 @@
                 <a:ea typeface="Inter" pitchFamily="34" charset="-122"/>
                 <a:cs typeface="Inter" pitchFamily="34" charset="-120"/>
               </a:rPr>
-              <a:t>Deckwerk</a:t>
-            </a:r>
-            <a:endParaRPr lang="de-DE" sz="975" dirty="0"/>
-          </a:p>
-        </p:txBody>
-      </p:sp>
-      <p:sp>
-        <p:nvSpPr>
-          <p:cNvPr id="27" name="dw:_footer.page"/>
-          <p:cNvSpPr/>
-          <p:nvPr/>
-        </p:nvSpPr>
-        <p:spPr>
-          <a:xfrm>
-            <a:off x="11427172" y="6450360"/>
-            <a:ext cx="80213" cy="148530"/>
-          </a:xfrm>
-          <a:prstGeom prst="rect">
-            <a:avLst/>
-          </a:prstGeom>
-          <a:noFill/>
-          <a:ln/>
-        </p:spPr>
-        <p:txBody>
-          <a:bodyPr wrap="square" lIns="0" tIns="0" rIns="0" bIns="0" rtlCol="0" anchor="t"/>
-          <a:lstStyle/>
-          <a:p>
-            <a:pPr algn="l" indent="0" marL="0">
-              <a:lnSpc>
-                <a:spcPts val="1170"/>
-              </a:lnSpc>
-              <a:buNone/>
-            </a:pPr>
-            <a:r>
-              <a:rPr lang="de-DE" altLang="en-US" sz="975" spc="20" kern="0" dirty="0">
-                <a:solidFill>
-                  <a:srgbClr val="575964"/>
-                </a:solidFill>
-                <a:latin typeface="Inter" pitchFamily="34" charset="0"/>
-                <a:ea typeface="Inter" pitchFamily="34" charset="-122"/>
-                <a:cs typeface="Inter" pitchFamily="34" charset="-120"/>
-              </a:rPr>
-              <a:t>3</a:t>
+              <a:t>3 / 12</a:t>
             </a:r>
             <a:endParaRPr lang="de-DE" sz="975" dirty="0"/>
           </a:p>
@@ -4780,7 +4544,7 @@
                               <p:par>
                                 <p:cTn id="25" presetID="42" presetClass="entr" presetSubtype="0" fill="hold" grpId="0" nodeType="withEffect">
                                   <p:stCondLst>
-                                    <p:cond delay="0"/>
+                                    <p:cond delay="150"/>
                                   </p:stCondLst>
                                   <p:childTnLst>
                                     <p:set>
@@ -4859,7 +4623,7 @@
                                 </p:cTn>
                               </p:par>
                               <p:par>
-                                <p:cTn id="30" presetID="42" presetClass="entr" presetSubtype="0" fill="hold" nodeType="withEffect">
+                                <p:cTn id="30" presetID="42" presetClass="entr" presetSubtype="0" fill="hold" grpId="0" nodeType="withEffect">
                                   <p:stCondLst>
                                     <p:cond delay="150"/>
                                   </p:stCondLst>
@@ -5104,7 +4868,7 @@
                               <p:par>
                                 <p:cTn id="45" presetID="42" presetClass="entr" presetSubtype="0" fill="hold" grpId="0" nodeType="withEffect">
                                   <p:stCondLst>
-                                    <p:cond delay="150"/>
+                                    <p:cond delay="300"/>
                                   </p:stCondLst>
                                   <p:childTnLst>
                                     <p:set>
@@ -5185,7 +4949,7 @@
                               <p:par>
                                 <p:cTn id="50" presetID="42" presetClass="entr" presetSubtype="0" fill="hold" grpId="0" nodeType="withEffect">
                                   <p:stCondLst>
-                                    <p:cond delay="150"/>
+                                    <p:cond delay="300"/>
                                   </p:stCondLst>
                                   <p:childTnLst>
                                     <p:set>
@@ -5266,7 +5030,7 @@
                               <p:par>
                                 <p:cTn id="55" presetID="42" presetClass="entr" presetSubtype="0" fill="hold" grpId="0" nodeType="withEffect">
                                   <p:stCondLst>
-                                    <p:cond delay="150"/>
+                                    <p:cond delay="300"/>
                                   </p:stCondLst>
                                   <p:childTnLst>
                                     <p:set>
@@ -5345,7 +5109,7 @@
                                 </p:cTn>
                               </p:par>
                               <p:par>
-                                <p:cTn id="60" presetID="42" presetClass="entr" presetSubtype="0" fill="hold" nodeType="withEffect">
+                                <p:cTn id="60" presetID="42" presetClass="entr" presetSubtype="0" fill="hold" grpId="0" nodeType="withEffect">
                                   <p:stCondLst>
                                     <p:cond delay="300"/>
                                   </p:stCondLst>
@@ -5428,7 +5192,7 @@
                               <p:par>
                                 <p:cTn id="65" presetID="42" presetClass="entr" presetSubtype="0" fill="hold" grpId="0" nodeType="withEffect">
                                   <p:stCondLst>
-                                    <p:cond delay="300"/>
+                                    <p:cond delay="450"/>
                                   </p:stCondLst>
                                   <p:childTnLst>
                                     <p:set>
@@ -5509,7 +5273,7 @@
                               <p:par>
                                 <p:cTn id="70" presetID="42" presetClass="entr" presetSubtype="0" fill="hold" grpId="0" nodeType="withEffect">
                                   <p:stCondLst>
-                                    <p:cond delay="300"/>
+                                    <p:cond delay="450"/>
                                   </p:stCondLst>
                                   <p:childTnLst>
                                     <p:set>
@@ -5590,7 +5354,7 @@
                               <p:par>
                                 <p:cTn id="75" presetID="42" presetClass="entr" presetSubtype="0" fill="hold" grpId="0" nodeType="withEffect">
                                   <p:stCondLst>
-                                    <p:cond delay="300"/>
+                                    <p:cond delay="450"/>
                                   </p:stCondLst>
                                   <p:childTnLst>
                                     <p:set>
@@ -5671,7 +5435,7 @@
                               <p:par>
                                 <p:cTn id="80" presetID="42" presetClass="entr" presetSubtype="0" fill="hold" grpId="0" nodeType="withEffect">
                                   <p:stCondLst>
-                                    <p:cond delay="300"/>
+                                    <p:cond delay="450"/>
                                   </p:stCondLst>
                                   <p:childTnLst>
                                     <p:set>
@@ -5728,573 +5492,6 @@
                                         <p:cTn id="84" dur="450" fill="hold"/>
                                         <p:tgtEl>
                                           <p:spTgt spid="18"/>
-                                        </p:tgtEl>
-                                        <p:attrNameLst>
-                                          <p:attrName>ppt_y</p:attrName>
-                                        </p:attrNameLst>
-                                      </p:cBhvr>
-                                      <p:tavLst>
-                                        <p:tav tm="0">
-                                          <p:val>
-                                            <p:strVal val="#ppt_y+.1"/>
-                                          </p:val>
-                                        </p:tav>
-                                        <p:tav tm="100000">
-                                          <p:val>
-                                            <p:strVal val="#ppt_y"/>
-                                          </p:val>
-                                        </p:tav>
-                                      </p:tavLst>
-                                    </p:anim>
-                                  </p:childTnLst>
-                                </p:cTn>
-                              </p:par>
-                              <p:par>
-                                <p:cTn id="85" presetID="42" presetClass="entr" presetSubtype="0" fill="hold" grpId="0" nodeType="withEffect">
-                                  <p:stCondLst>
-                                    <p:cond delay="300"/>
-                                  </p:stCondLst>
-                                  <p:childTnLst>
-                                    <p:set>
-                                      <p:cBhvr>
-                                        <p:cTn id="86" dur="1" fill="hold">
-                                          <p:stCondLst>
-                                            <p:cond delay="0"/>
-                                          </p:stCondLst>
-                                        </p:cTn>
-                                        <p:tgtEl>
-                                          <p:spTgt spid="19"/>
-                                        </p:tgtEl>
-                                        <p:attrNameLst>
-                                          <p:attrName>style.visibility</p:attrName>
-                                        </p:attrNameLst>
-                                      </p:cBhvr>
-                                      <p:to>
-                                        <p:strVal val="visible"/>
-                                      </p:to>
-                                    </p:set>
-                                    <p:animEffect transition="in" filter="fade">
-                                      <p:cBhvr>
-                                        <p:cTn id="87" dur="450"/>
-                                        <p:tgtEl>
-                                          <p:spTgt spid="19"/>
-                                        </p:tgtEl>
-                                      </p:cBhvr>
-                                    </p:animEffect>
-                                    <p:anim calcmode="lin" valueType="num">
-                                      <p:cBhvr>
-                                        <p:cTn id="88" dur="450" fill="hold"/>
-                                        <p:tgtEl>
-                                          <p:spTgt spid="19"/>
-                                        </p:tgtEl>
-                                        <p:attrNameLst>
-                                          <p:attrName>ppt_x</p:attrName>
-                                        </p:attrNameLst>
-                                      </p:cBhvr>
-                                      <p:tavLst>
-                                        <p:tav tm="0">
-                                          <p:val>
-                                            <p:strVal val="#ppt_x"/>
-                                          </p:val>
-                                        </p:tav>
-                                        <p:tav tm="100000">
-                                          <p:val>
-                                            <p:strVal val="#ppt_x"/>
-                                          </p:val>
-                                        </p:tav>
-                                      </p:tavLst>
-                                    </p:anim>
-                                    <p:anim calcmode="lin" valueType="num">
-                                      <p:cBhvr>
-                                        <p:cTn id="89" dur="450" fill="hold"/>
-                                        <p:tgtEl>
-                                          <p:spTgt spid="19"/>
-                                        </p:tgtEl>
-                                        <p:attrNameLst>
-                                          <p:attrName>ppt_y</p:attrName>
-                                        </p:attrNameLst>
-                                      </p:cBhvr>
-                                      <p:tavLst>
-                                        <p:tav tm="0">
-                                          <p:val>
-                                            <p:strVal val="#ppt_y+.1"/>
-                                          </p:val>
-                                        </p:tav>
-                                        <p:tav tm="100000">
-                                          <p:val>
-                                            <p:strVal val="#ppt_y"/>
-                                          </p:val>
-                                        </p:tav>
-                                      </p:tavLst>
-                                    </p:anim>
-                                  </p:childTnLst>
-                                </p:cTn>
-                              </p:par>
-                              <p:par>
-                                <p:cTn id="90" presetID="42" presetClass="entr" presetSubtype="0" fill="hold" nodeType="withEffect">
-                                  <p:stCondLst>
-                                    <p:cond delay="450"/>
-                                  </p:stCondLst>
-                                  <p:childTnLst>
-                                    <p:set>
-                                      <p:cBhvr>
-                                        <p:cTn id="91" dur="1" fill="hold">
-                                          <p:stCondLst>
-                                            <p:cond delay="0"/>
-                                          </p:stCondLst>
-                                        </p:cTn>
-                                        <p:tgtEl>
-                                          <p:spTgt spid="20"/>
-                                        </p:tgtEl>
-                                        <p:attrNameLst>
-                                          <p:attrName>style.visibility</p:attrName>
-                                        </p:attrNameLst>
-                                      </p:cBhvr>
-                                      <p:to>
-                                        <p:strVal val="visible"/>
-                                      </p:to>
-                                    </p:set>
-                                    <p:animEffect transition="in" filter="fade">
-                                      <p:cBhvr>
-                                        <p:cTn id="92" dur="450"/>
-                                        <p:tgtEl>
-                                          <p:spTgt spid="20"/>
-                                        </p:tgtEl>
-                                      </p:cBhvr>
-                                    </p:animEffect>
-                                    <p:anim calcmode="lin" valueType="num">
-                                      <p:cBhvr>
-                                        <p:cTn id="93" dur="450" fill="hold"/>
-                                        <p:tgtEl>
-                                          <p:spTgt spid="20"/>
-                                        </p:tgtEl>
-                                        <p:attrNameLst>
-                                          <p:attrName>ppt_x</p:attrName>
-                                        </p:attrNameLst>
-                                      </p:cBhvr>
-                                      <p:tavLst>
-                                        <p:tav tm="0">
-                                          <p:val>
-                                            <p:strVal val="#ppt_x"/>
-                                          </p:val>
-                                        </p:tav>
-                                        <p:tav tm="100000">
-                                          <p:val>
-                                            <p:strVal val="#ppt_x"/>
-                                          </p:val>
-                                        </p:tav>
-                                      </p:tavLst>
-                                    </p:anim>
-                                    <p:anim calcmode="lin" valueType="num">
-                                      <p:cBhvr>
-                                        <p:cTn id="94" dur="450" fill="hold"/>
-                                        <p:tgtEl>
-                                          <p:spTgt spid="20"/>
-                                        </p:tgtEl>
-                                        <p:attrNameLst>
-                                          <p:attrName>ppt_y</p:attrName>
-                                        </p:attrNameLst>
-                                      </p:cBhvr>
-                                      <p:tavLst>
-                                        <p:tav tm="0">
-                                          <p:val>
-                                            <p:strVal val="#ppt_y+.1"/>
-                                          </p:val>
-                                        </p:tav>
-                                        <p:tav tm="100000">
-                                          <p:val>
-                                            <p:strVal val="#ppt_y"/>
-                                          </p:val>
-                                        </p:tav>
-                                      </p:tavLst>
-                                    </p:anim>
-                                  </p:childTnLst>
-                                </p:cTn>
-                              </p:par>
-                              <p:par>
-                                <p:cTn id="95" presetID="42" presetClass="entr" presetSubtype="0" fill="hold" grpId="0" nodeType="withEffect">
-                                  <p:stCondLst>
-                                    <p:cond delay="450"/>
-                                  </p:stCondLst>
-                                  <p:childTnLst>
-                                    <p:set>
-                                      <p:cBhvr>
-                                        <p:cTn id="96" dur="1" fill="hold">
-                                          <p:stCondLst>
-                                            <p:cond delay="0"/>
-                                          </p:stCondLst>
-                                        </p:cTn>
-                                        <p:tgtEl>
-                                          <p:spTgt spid="21"/>
-                                        </p:tgtEl>
-                                        <p:attrNameLst>
-                                          <p:attrName>style.visibility</p:attrName>
-                                        </p:attrNameLst>
-                                      </p:cBhvr>
-                                      <p:to>
-                                        <p:strVal val="visible"/>
-                                      </p:to>
-                                    </p:set>
-                                    <p:animEffect transition="in" filter="fade">
-                                      <p:cBhvr>
-                                        <p:cTn id="97" dur="450"/>
-                                        <p:tgtEl>
-                                          <p:spTgt spid="21"/>
-                                        </p:tgtEl>
-                                      </p:cBhvr>
-                                    </p:animEffect>
-                                    <p:anim calcmode="lin" valueType="num">
-                                      <p:cBhvr>
-                                        <p:cTn id="98" dur="450" fill="hold"/>
-                                        <p:tgtEl>
-                                          <p:spTgt spid="21"/>
-                                        </p:tgtEl>
-                                        <p:attrNameLst>
-                                          <p:attrName>ppt_x</p:attrName>
-                                        </p:attrNameLst>
-                                      </p:cBhvr>
-                                      <p:tavLst>
-                                        <p:tav tm="0">
-                                          <p:val>
-                                            <p:strVal val="#ppt_x"/>
-                                          </p:val>
-                                        </p:tav>
-                                        <p:tav tm="100000">
-                                          <p:val>
-                                            <p:strVal val="#ppt_x"/>
-                                          </p:val>
-                                        </p:tav>
-                                      </p:tavLst>
-                                    </p:anim>
-                                    <p:anim calcmode="lin" valueType="num">
-                                      <p:cBhvr>
-                                        <p:cTn id="99" dur="450" fill="hold"/>
-                                        <p:tgtEl>
-                                          <p:spTgt spid="21"/>
-                                        </p:tgtEl>
-                                        <p:attrNameLst>
-                                          <p:attrName>ppt_y</p:attrName>
-                                        </p:attrNameLst>
-                                      </p:cBhvr>
-                                      <p:tavLst>
-                                        <p:tav tm="0">
-                                          <p:val>
-                                            <p:strVal val="#ppt_y+.1"/>
-                                          </p:val>
-                                        </p:tav>
-                                        <p:tav tm="100000">
-                                          <p:val>
-                                            <p:strVal val="#ppt_y"/>
-                                          </p:val>
-                                        </p:tav>
-                                      </p:tavLst>
-                                    </p:anim>
-                                  </p:childTnLst>
-                                </p:cTn>
-                              </p:par>
-                              <p:par>
-                                <p:cTn id="100" presetID="42" presetClass="entr" presetSubtype="0" fill="hold" grpId="0" nodeType="withEffect">
-                                  <p:stCondLst>
-                                    <p:cond delay="450"/>
-                                  </p:stCondLst>
-                                  <p:childTnLst>
-                                    <p:set>
-                                      <p:cBhvr>
-                                        <p:cTn id="101" dur="1" fill="hold">
-                                          <p:stCondLst>
-                                            <p:cond delay="0"/>
-                                          </p:stCondLst>
-                                        </p:cTn>
-                                        <p:tgtEl>
-                                          <p:spTgt spid="22"/>
-                                        </p:tgtEl>
-                                        <p:attrNameLst>
-                                          <p:attrName>style.visibility</p:attrName>
-                                        </p:attrNameLst>
-                                      </p:cBhvr>
-                                      <p:to>
-                                        <p:strVal val="visible"/>
-                                      </p:to>
-                                    </p:set>
-                                    <p:animEffect transition="in" filter="fade">
-                                      <p:cBhvr>
-                                        <p:cTn id="102" dur="450"/>
-                                        <p:tgtEl>
-                                          <p:spTgt spid="22"/>
-                                        </p:tgtEl>
-                                      </p:cBhvr>
-                                    </p:animEffect>
-                                    <p:anim calcmode="lin" valueType="num">
-                                      <p:cBhvr>
-                                        <p:cTn id="103" dur="450" fill="hold"/>
-                                        <p:tgtEl>
-                                          <p:spTgt spid="22"/>
-                                        </p:tgtEl>
-                                        <p:attrNameLst>
-                                          <p:attrName>ppt_x</p:attrName>
-                                        </p:attrNameLst>
-                                      </p:cBhvr>
-                                      <p:tavLst>
-                                        <p:tav tm="0">
-                                          <p:val>
-                                            <p:strVal val="#ppt_x"/>
-                                          </p:val>
-                                        </p:tav>
-                                        <p:tav tm="100000">
-                                          <p:val>
-                                            <p:strVal val="#ppt_x"/>
-                                          </p:val>
-                                        </p:tav>
-                                      </p:tavLst>
-                                    </p:anim>
-                                    <p:anim calcmode="lin" valueType="num">
-                                      <p:cBhvr>
-                                        <p:cTn id="104" dur="450" fill="hold"/>
-                                        <p:tgtEl>
-                                          <p:spTgt spid="22"/>
-                                        </p:tgtEl>
-                                        <p:attrNameLst>
-                                          <p:attrName>ppt_y</p:attrName>
-                                        </p:attrNameLst>
-                                      </p:cBhvr>
-                                      <p:tavLst>
-                                        <p:tav tm="0">
-                                          <p:val>
-                                            <p:strVal val="#ppt_y+.1"/>
-                                          </p:val>
-                                        </p:tav>
-                                        <p:tav tm="100000">
-                                          <p:val>
-                                            <p:strVal val="#ppt_y"/>
-                                          </p:val>
-                                        </p:tav>
-                                      </p:tavLst>
-                                    </p:anim>
-                                  </p:childTnLst>
-                                </p:cTn>
-                              </p:par>
-                              <p:par>
-                                <p:cTn id="105" presetID="42" presetClass="entr" presetSubtype="0" fill="hold" grpId="0" nodeType="withEffect">
-                                  <p:stCondLst>
-                                    <p:cond delay="450"/>
-                                  </p:stCondLst>
-                                  <p:childTnLst>
-                                    <p:set>
-                                      <p:cBhvr>
-                                        <p:cTn id="106" dur="1" fill="hold">
-                                          <p:stCondLst>
-                                            <p:cond delay="0"/>
-                                          </p:stCondLst>
-                                        </p:cTn>
-                                        <p:tgtEl>
-                                          <p:spTgt spid="23"/>
-                                        </p:tgtEl>
-                                        <p:attrNameLst>
-                                          <p:attrName>style.visibility</p:attrName>
-                                        </p:attrNameLst>
-                                      </p:cBhvr>
-                                      <p:to>
-                                        <p:strVal val="visible"/>
-                                      </p:to>
-                                    </p:set>
-                                    <p:animEffect transition="in" filter="fade">
-                                      <p:cBhvr>
-                                        <p:cTn id="107" dur="450"/>
-                                        <p:tgtEl>
-                                          <p:spTgt spid="23"/>
-                                        </p:tgtEl>
-                                      </p:cBhvr>
-                                    </p:animEffect>
-                                    <p:anim calcmode="lin" valueType="num">
-                                      <p:cBhvr>
-                                        <p:cTn id="108" dur="450" fill="hold"/>
-                                        <p:tgtEl>
-                                          <p:spTgt spid="23"/>
-                                        </p:tgtEl>
-                                        <p:attrNameLst>
-                                          <p:attrName>ppt_x</p:attrName>
-                                        </p:attrNameLst>
-                                      </p:cBhvr>
-                                      <p:tavLst>
-                                        <p:tav tm="0">
-                                          <p:val>
-                                            <p:strVal val="#ppt_x"/>
-                                          </p:val>
-                                        </p:tav>
-                                        <p:tav tm="100000">
-                                          <p:val>
-                                            <p:strVal val="#ppt_x"/>
-                                          </p:val>
-                                        </p:tav>
-                                      </p:tavLst>
-                                    </p:anim>
-                                    <p:anim calcmode="lin" valueType="num">
-                                      <p:cBhvr>
-                                        <p:cTn id="109" dur="450" fill="hold"/>
-                                        <p:tgtEl>
-                                          <p:spTgt spid="23"/>
-                                        </p:tgtEl>
-                                        <p:attrNameLst>
-                                          <p:attrName>ppt_y</p:attrName>
-                                        </p:attrNameLst>
-                                      </p:cBhvr>
-                                      <p:tavLst>
-                                        <p:tav tm="0">
-                                          <p:val>
-                                            <p:strVal val="#ppt_y+.1"/>
-                                          </p:val>
-                                        </p:tav>
-                                        <p:tav tm="100000">
-                                          <p:val>
-                                            <p:strVal val="#ppt_y"/>
-                                          </p:val>
-                                        </p:tav>
-                                      </p:tavLst>
-                                    </p:anim>
-                                  </p:childTnLst>
-                                </p:cTn>
-                              </p:par>
-                              <p:par>
-                                <p:cTn id="110" presetID="42" presetClass="entr" presetSubtype="0" fill="hold" grpId="0" nodeType="withEffect">
-                                  <p:stCondLst>
-                                    <p:cond delay="450"/>
-                                  </p:stCondLst>
-                                  <p:childTnLst>
-                                    <p:set>
-                                      <p:cBhvr>
-                                        <p:cTn id="111" dur="1" fill="hold">
-                                          <p:stCondLst>
-                                            <p:cond delay="0"/>
-                                          </p:stCondLst>
-                                        </p:cTn>
-                                        <p:tgtEl>
-                                          <p:spTgt spid="24"/>
-                                        </p:tgtEl>
-                                        <p:attrNameLst>
-                                          <p:attrName>style.visibility</p:attrName>
-                                        </p:attrNameLst>
-                                      </p:cBhvr>
-                                      <p:to>
-                                        <p:strVal val="visible"/>
-                                      </p:to>
-                                    </p:set>
-                                    <p:animEffect transition="in" filter="fade">
-                                      <p:cBhvr>
-                                        <p:cTn id="112" dur="450"/>
-                                        <p:tgtEl>
-                                          <p:spTgt spid="24"/>
-                                        </p:tgtEl>
-                                      </p:cBhvr>
-                                    </p:animEffect>
-                                    <p:anim calcmode="lin" valueType="num">
-                                      <p:cBhvr>
-                                        <p:cTn id="113" dur="450" fill="hold"/>
-                                        <p:tgtEl>
-                                          <p:spTgt spid="24"/>
-                                        </p:tgtEl>
-                                        <p:attrNameLst>
-                                          <p:attrName>ppt_x</p:attrName>
-                                        </p:attrNameLst>
-                                      </p:cBhvr>
-                                      <p:tavLst>
-                                        <p:tav tm="0">
-                                          <p:val>
-                                            <p:strVal val="#ppt_x"/>
-                                          </p:val>
-                                        </p:tav>
-                                        <p:tav tm="100000">
-                                          <p:val>
-                                            <p:strVal val="#ppt_x"/>
-                                          </p:val>
-                                        </p:tav>
-                                      </p:tavLst>
-                                    </p:anim>
-                                    <p:anim calcmode="lin" valueType="num">
-                                      <p:cBhvr>
-                                        <p:cTn id="114" dur="450" fill="hold"/>
-                                        <p:tgtEl>
-                                          <p:spTgt spid="24"/>
-                                        </p:tgtEl>
-                                        <p:attrNameLst>
-                                          <p:attrName>ppt_y</p:attrName>
-                                        </p:attrNameLst>
-                                      </p:cBhvr>
-                                      <p:tavLst>
-                                        <p:tav tm="0">
-                                          <p:val>
-                                            <p:strVal val="#ppt_y+.1"/>
-                                          </p:val>
-                                        </p:tav>
-                                        <p:tav tm="100000">
-                                          <p:val>
-                                            <p:strVal val="#ppt_y"/>
-                                          </p:val>
-                                        </p:tav>
-                                      </p:tavLst>
-                                    </p:anim>
-                                  </p:childTnLst>
-                                </p:cTn>
-                              </p:par>
-                              <p:par>
-                                <p:cTn id="115" presetID="42" presetClass="entr" presetSubtype="0" fill="hold" grpId="0" nodeType="withEffect">
-                                  <p:stCondLst>
-                                    <p:cond delay="450"/>
-                                  </p:stCondLst>
-                                  <p:childTnLst>
-                                    <p:set>
-                                      <p:cBhvr>
-                                        <p:cTn id="116" dur="1" fill="hold">
-                                          <p:stCondLst>
-                                            <p:cond delay="0"/>
-                                          </p:stCondLst>
-                                        </p:cTn>
-                                        <p:tgtEl>
-                                          <p:spTgt spid="25"/>
-                                        </p:tgtEl>
-                                        <p:attrNameLst>
-                                          <p:attrName>style.visibility</p:attrName>
-                                        </p:attrNameLst>
-                                      </p:cBhvr>
-                                      <p:to>
-                                        <p:strVal val="visible"/>
-                                      </p:to>
-                                    </p:set>
-                                    <p:animEffect transition="in" filter="fade">
-                                      <p:cBhvr>
-                                        <p:cTn id="117" dur="450"/>
-                                        <p:tgtEl>
-                                          <p:spTgt spid="25"/>
-                                        </p:tgtEl>
-                                      </p:cBhvr>
-                                    </p:animEffect>
-                                    <p:anim calcmode="lin" valueType="num">
-                                      <p:cBhvr>
-                                        <p:cTn id="118" dur="450" fill="hold"/>
-                                        <p:tgtEl>
-                                          <p:spTgt spid="25"/>
-                                        </p:tgtEl>
-                                        <p:attrNameLst>
-                                          <p:attrName>ppt_x</p:attrName>
-                                        </p:attrNameLst>
-                                      </p:cBhvr>
-                                      <p:tavLst>
-                                        <p:tav tm="0">
-                                          <p:val>
-                                            <p:strVal val="#ppt_x"/>
-                                          </p:val>
-                                        </p:tav>
-                                        <p:tav tm="100000">
-                                          <p:val>
-                                            <p:strVal val="#ppt_x"/>
-                                          </p:val>
-                                        </p:tav>
-                                      </p:tavLst>
-                                    </p:anim>
-                                    <p:anim calcmode="lin" valueType="num">
-                                      <p:cBhvr>
-                                        <p:cTn id="119" dur="450" fill="hold"/>
-                                        <p:tgtEl>
-                                          <p:spTgt spid="25"/>
                                         </p:tgtEl>
                                         <p:attrNameLst>
                                           <p:attrName>ppt_y</p:attrName>
@@ -6349,21 +5546,17 @@
       <p:bldP spid="5" grpId="0" animBg="1"/>
       <p:bldP spid="6" grpId="0" animBg="1"/>
       <p:bldP spid="7" grpId="0" animBg="1"/>
+      <p:bldP spid="8" grpId="0" animBg="1"/>
       <p:bldP spid="9" grpId="0" animBg="1"/>
       <p:bldP spid="10" grpId="0" animBg="1"/>
       <p:bldP spid="11" grpId="0" animBg="1"/>
       <p:bldP spid="12" grpId="0" animBg="1"/>
       <p:bldP spid="13" grpId="0" animBg="1"/>
+      <p:bldP spid="14" grpId="0" animBg="1"/>
       <p:bldP spid="15" grpId="0" animBg="1"/>
       <p:bldP spid="16" grpId="0" animBg="1"/>
       <p:bldP spid="17" grpId="0" animBg="1"/>
       <p:bldP spid="18" grpId="0" animBg="1"/>
-      <p:bldP spid="19" grpId="0" animBg="1"/>
-      <p:bldP spid="21" grpId="0" animBg="1"/>
-      <p:bldP spid="22" grpId="0" animBg="1"/>
-      <p:bldP spid="23" grpId="0" animBg="1"/>
-      <p:bldP spid="24" grpId="0" animBg="1"/>
-      <p:bldP spid="25" grpId="0" animBg="1"/>
     </p:bldLst>
   </p:timing>
 </p:sld>
@@ -7022,14 +6215,14 @@
       </p:sp>
       <p:sp>
         <p:nvSpPr>
-          <p:cNvPr id="21" name="dw:_footer.title"/>
+          <p:cNvPr id="21" name="dw:_footer.page"/>
           <p:cNvSpPr/>
           <p:nvPr/>
         </p:nvSpPr>
         <p:spPr>
           <a:xfrm>
-            <a:off x="685800" y="6450360"/>
-            <a:ext cx="617007" cy="148530"/>
+            <a:off x="11171188" y="6450360"/>
+            <a:ext cx="340037" cy="148530"/>
           </a:xfrm>
           <a:prstGeom prst="rect">
             <a:avLst/>
@@ -7056,49 +6249,7 @@
                 <a:ea typeface="Inter" pitchFamily="34" charset="-122"/>
                 <a:cs typeface="Inter" pitchFamily="34" charset="-120"/>
               </a:rPr>
-              <a:t>Deckwerk</a:t>
-            </a:r>
-            <a:endParaRPr lang="de-DE" sz="975" dirty="0"/>
-          </a:p>
-        </p:txBody>
-      </p:sp>
-      <p:sp>
-        <p:nvSpPr>
-          <p:cNvPr id="22" name="dw:_footer.page"/>
-          <p:cNvSpPr/>
-          <p:nvPr/>
-        </p:nvSpPr>
-        <p:spPr>
-          <a:xfrm>
-            <a:off x="11423675" y="6450360"/>
-            <a:ext cx="83763" cy="148530"/>
-          </a:xfrm>
-          <a:prstGeom prst="rect">
-            <a:avLst/>
-          </a:prstGeom>
-          <a:noFill/>
-          <a:ln/>
-        </p:spPr>
-        <p:txBody>
-          <a:bodyPr wrap="square" lIns="0" tIns="0" rIns="0" bIns="0" rtlCol="0" anchor="t"/>
-          <a:lstStyle/>
-          <a:p>
-            <a:pPr algn="l" indent="0" marL="0">
-              <a:lnSpc>
-                <a:spcPts val="1170"/>
-              </a:lnSpc>
-              <a:buNone/>
-            </a:pPr>
-            <a:r>
-              <a:rPr lang="de-DE" altLang="en-US" sz="975" spc="20" kern="0" dirty="0">
-                <a:solidFill>
-                  <a:srgbClr val="575964"/>
-                </a:solidFill>
-                <a:latin typeface="Inter" pitchFamily="34" charset="0"/>
-                <a:ea typeface="Inter" pitchFamily="34" charset="-122"/>
-                <a:cs typeface="Inter" pitchFamily="34" charset="-120"/>
-              </a:rPr>
-              <a:t>4</a:t>
+              <a:t>4 / 12</a:t>
             </a:r>
             <a:endParaRPr lang="de-DE" sz="975" dirty="0"/>
           </a:p>
@@ -8820,90 +7971,6 @@
           </a:p>
         </p:txBody>
       </p:sp>
-      <p:sp>
-        <p:nvSpPr>
-          <p:cNvPr id="5" name="dw:_footer.title"/>
-          <p:cNvSpPr/>
-          <p:nvPr/>
-        </p:nvSpPr>
-        <p:spPr>
-          <a:xfrm>
-            <a:off x="685800" y="6450360"/>
-            <a:ext cx="617007" cy="148530"/>
-          </a:xfrm>
-          <a:prstGeom prst="rect">
-            <a:avLst/>
-          </a:prstGeom>
-          <a:noFill/>
-          <a:ln/>
-        </p:spPr>
-        <p:txBody>
-          <a:bodyPr wrap="square" lIns="0" tIns="0" rIns="0" bIns="0" rtlCol="0" anchor="t"/>
-          <a:lstStyle/>
-          <a:p>
-            <a:pPr algn="l" indent="0" marL="0">
-              <a:lnSpc>
-                <a:spcPts val="1170"/>
-              </a:lnSpc>
-              <a:buNone/>
-            </a:pPr>
-            <a:r>
-              <a:rPr lang="de-DE" altLang="en-US" sz="975" spc="20" kern="0" dirty="0">
-                <a:solidFill>
-                  <a:srgbClr val="575964"/>
-                </a:solidFill>
-                <a:latin typeface="Inter" pitchFamily="34" charset="0"/>
-                <a:ea typeface="Inter" pitchFamily="34" charset="-122"/>
-                <a:cs typeface="Inter" pitchFamily="34" charset="-120"/>
-              </a:rPr>
-              <a:t>Deckwerk</a:t>
-            </a:r>
-            <a:endParaRPr lang="de-DE" sz="975" dirty="0"/>
-          </a:p>
-        </p:txBody>
-      </p:sp>
-      <p:sp>
-        <p:nvSpPr>
-          <p:cNvPr id="6" name="dw:_footer.page"/>
-          <p:cNvSpPr/>
-          <p:nvPr/>
-        </p:nvSpPr>
-        <p:spPr>
-          <a:xfrm>
-            <a:off x="11430223" y="6450360"/>
-            <a:ext cx="77116" cy="148530"/>
-          </a:xfrm>
-          <a:prstGeom prst="rect">
-            <a:avLst/>
-          </a:prstGeom>
-          <a:noFill/>
-          <a:ln/>
-        </p:spPr>
-        <p:txBody>
-          <a:bodyPr wrap="square" lIns="0" tIns="0" rIns="0" bIns="0" rtlCol="0" anchor="t"/>
-          <a:lstStyle/>
-          <a:p>
-            <a:pPr algn="l" indent="0" marL="0">
-              <a:lnSpc>
-                <a:spcPts val="1170"/>
-              </a:lnSpc>
-              <a:buNone/>
-            </a:pPr>
-            <a:r>
-              <a:rPr lang="de-DE" altLang="en-US" sz="975" spc="20" kern="0" dirty="0">
-                <a:solidFill>
-                  <a:srgbClr val="575964"/>
-                </a:solidFill>
-                <a:latin typeface="Inter" pitchFamily="34" charset="0"/>
-                <a:ea typeface="Inter" pitchFamily="34" charset="-122"/>
-                <a:cs typeface="Inter" pitchFamily="34" charset="-120"/>
-              </a:rPr>
-              <a:t>5</a:t>
-            </a:r>
-            <a:endParaRPr lang="de-DE" sz="975" dirty="0"/>
-          </a:p>
-        </p:txBody>
-      </p:sp>
     </p:spTree>
   </p:cSld>
   <p:clrMapOvr>
@@ -9253,7 +8320,7 @@
         </p:nvSpPr>
         <p:spPr>
           <a:xfrm>
-            <a:off x="685800" y="2192238"/>
+            <a:off x="685800" y="3698751"/>
             <a:ext cx="9474518" cy="1872258"/>
           </a:xfrm>
           <a:prstGeom prst="rect">
@@ -9315,7 +8382,7 @@
         </p:nvSpPr>
         <p:spPr>
           <a:xfrm>
-            <a:off x="685800" y="4235946"/>
+            <a:off x="685800" y="5742459"/>
             <a:ext cx="7540943" cy="315441"/>
           </a:xfrm>
           <a:prstGeom prst="rect">
@@ -9822,7 +8889,7 @@
         <p:spPr>
           <a:xfrm>
             <a:off x="5334000" y="6450360"/>
-            <a:ext cx="617007" cy="148530"/>
+            <a:ext cx="1675790" cy="148530"/>
           </a:xfrm>
           <a:prstGeom prst="rect">
             <a:avLst/>
@@ -9849,7 +8916,7 @@
                 <a:ea typeface="Inter" pitchFamily="34" charset="-122"/>
                 <a:cs typeface="Inter" pitchFamily="34" charset="-120"/>
               </a:rPr>
-              <a:t>Deckwerk</a:t>
+              <a:t>Geprüft, bevor du es siehst</a:t>
             </a:r>
             <a:endParaRPr lang="de-DE" sz="975" dirty="0"/>
           </a:p>
@@ -9863,8 +8930,8 @@
         </p:nvSpPr>
         <p:spPr>
           <a:xfrm>
-            <a:off x="11433646" y="6450360"/>
-            <a:ext cx="73642" cy="148530"/>
+            <a:off x="11181085" y="6450360"/>
+            <a:ext cx="329992" cy="148530"/>
           </a:xfrm>
           <a:prstGeom prst="rect">
             <a:avLst/>
@@ -9891,7 +8958,7 @@
                 <a:ea typeface="Inter" pitchFamily="34" charset="-122"/>
                 <a:cs typeface="Inter" pitchFamily="34" charset="-120"/>
               </a:rPr>
-              <a:t>7</a:t>
+              <a:t>7 / 12</a:t>
             </a:r>
             <a:endParaRPr lang="de-DE" sz="975" dirty="0"/>
           </a:p>
@@ -11604,7 +10671,7 @@
         <p:spPr>
           <a:xfrm>
             <a:off x="685800" y="6450360"/>
-            <a:ext cx="617007" cy="148530"/>
+            <a:ext cx="1675790" cy="148530"/>
           </a:xfrm>
           <a:prstGeom prst="rect">
             <a:avLst/>
@@ -11631,7 +10698,7 @@
                 <a:ea typeface="Inter" pitchFamily="34" charset="-122"/>
                 <a:cs typeface="Inter" pitchFamily="34" charset="-120"/>
               </a:rPr>
-              <a:t>Deckwerk</a:t>
+              <a:t>Geprüft, bevor du es siehst</a:t>
             </a:r>
             <a:endParaRPr lang="de-DE" sz="975" dirty="0"/>
           </a:p>
@@ -11645,8 +10712,8 @@
         </p:nvSpPr>
         <p:spPr>
           <a:xfrm>
-            <a:off x="11427098" y="6450360"/>
-            <a:ext cx="80289" cy="148530"/>
+            <a:off x="11174537" y="6450360"/>
+            <a:ext cx="336638" cy="148530"/>
           </a:xfrm>
           <a:prstGeom prst="rect">
             <a:avLst/>
@@ -11673,7 +10740,7 @@
                 <a:ea typeface="Inter" pitchFamily="34" charset="-122"/>
                 <a:cs typeface="Inter" pitchFamily="34" charset="-120"/>
               </a:rPr>
-              <a:t>8</a:t>
+              <a:t>8 / 12</a:t>
             </a:r>
             <a:endParaRPr lang="de-DE" sz="975" dirty="0"/>
           </a:p>
@@ -12421,7 +11488,7 @@
         <p:spPr>
           <a:xfrm>
             <a:off x="685800" y="2065288"/>
-            <a:ext cx="3271242" cy="1673126"/>
+            <a:ext cx="3271242" cy="1853133"/>
           </a:xfrm>
           <a:prstGeom prst="rect">
             <a:avLst/>
@@ -12438,7 +11505,7 @@
         <p:spPr>
           <a:xfrm>
             <a:off x="685800" y="2141488"/>
-            <a:ext cx="3049610" cy="900113"/>
+            <a:ext cx="3049610" cy="1080120"/>
           </a:xfrm>
           <a:prstGeom prst="rect">
             <a:avLst/>
@@ -12452,12 +11519,12 @@
           <a:p>
             <a:pPr algn="l" indent="0" marL="0">
               <a:lnSpc>
-                <a:spcPts val="7088"/>
+                <a:spcPts val="8505"/>
               </a:lnSpc>
               <a:buNone/>
             </a:pPr>
             <a:r>
-              <a:rPr lang="de-DE" altLang="en-US" sz="6750" b="1" spc="-203" kern="0" dirty="0">
+              <a:rPr lang="de-DE" altLang="en-US" sz="8100" b="1" spc="-243" kern="0" dirty="0">
                 <a:solidFill>
                   <a:srgbClr val="4F52D9"/>
                 </a:solidFill>
@@ -12467,7 +11534,7 @@
               </a:rPr>
               <a:t>8</a:t>
             </a:r>
-            <a:endParaRPr lang="de-DE" sz="6750" dirty="0"/>
+            <a:endParaRPr lang="de-DE" sz="8100" dirty="0"/>
           </a:p>
         </p:txBody>
       </p:sp>
@@ -12479,7 +11546,7 @@
         </p:nvSpPr>
         <p:spPr>
           <a:xfrm>
-            <a:off x="685800" y="3136850"/>
+            <a:off x="685800" y="3316858"/>
             <a:ext cx="3049610" cy="477738"/>
           </a:xfrm>
           <a:prstGeom prst="rect">
@@ -12522,7 +11589,7 @@
         <p:spPr>
           <a:xfrm>
             <a:off x="3957042" y="2065288"/>
-            <a:ext cx="2516386" cy="1673126"/>
+            <a:ext cx="2516386" cy="1853133"/>
           </a:xfrm>
           <a:prstGeom prst="rect">
             <a:avLst/>
@@ -12539,7 +11606,7 @@
         <p:spPr>
           <a:xfrm>
             <a:off x="3957042" y="2141488"/>
-            <a:ext cx="19050" cy="1520726"/>
+            <a:ext cx="19050" cy="1700733"/>
           </a:xfrm>
           <a:prstGeom prst="rect">
             <a:avLst/>
@@ -12558,7 +11625,7 @@
         </p:nvSpPr>
         <p:spPr>
           <a:xfrm>
-            <a:off x="4223742" y="2289125"/>
+            <a:off x="4223742" y="2436763"/>
             <a:ext cx="2012731" cy="720030"/>
           </a:xfrm>
           <a:prstGeom prst="rect">
@@ -12600,7 +11667,7 @@
         </p:nvSpPr>
         <p:spPr>
           <a:xfrm>
-            <a:off x="4223742" y="3136850"/>
+            <a:off x="4223742" y="3316858"/>
             <a:ext cx="2012731" cy="477738"/>
           </a:xfrm>
           <a:prstGeom prst="rect">
@@ -12643,7 +11710,7 @@
         <p:spPr>
           <a:xfrm>
             <a:off x="6473428" y="2065288"/>
-            <a:ext cx="2516386" cy="1673126"/>
+            <a:ext cx="2516386" cy="1853133"/>
           </a:xfrm>
           <a:prstGeom prst="rect">
             <a:avLst/>
@@ -12660,7 +11727,7 @@
         <p:spPr>
           <a:xfrm>
             <a:off x="6473428" y="2141488"/>
-            <a:ext cx="19050" cy="1520726"/>
+            <a:ext cx="19050" cy="1700733"/>
           </a:xfrm>
           <a:prstGeom prst="rect">
             <a:avLst/>
@@ -12679,7 +11746,7 @@
         </p:nvSpPr>
         <p:spPr>
           <a:xfrm>
-            <a:off x="6740128" y="2289125"/>
+            <a:off x="6740128" y="2436763"/>
             <a:ext cx="2012731" cy="720030"/>
           </a:xfrm>
           <a:prstGeom prst="rect">
@@ -12721,7 +11788,7 @@
         </p:nvSpPr>
         <p:spPr>
           <a:xfrm>
-            <a:off x="6740128" y="3136850"/>
+            <a:off x="6740128" y="3316858"/>
             <a:ext cx="2012731" cy="477738"/>
           </a:xfrm>
           <a:prstGeom prst="rect">
@@ -12764,7 +11831,7 @@
         <p:spPr>
           <a:xfrm>
             <a:off x="8989814" y="2065288"/>
-            <a:ext cx="2516312" cy="1673126"/>
+            <a:ext cx="2516312" cy="1853133"/>
           </a:xfrm>
           <a:prstGeom prst="rect">
             <a:avLst/>
@@ -12781,7 +11848,7 @@
         <p:spPr>
           <a:xfrm>
             <a:off x="8989814" y="2141488"/>
-            <a:ext cx="19050" cy="1520726"/>
+            <a:ext cx="19050" cy="1700733"/>
           </a:xfrm>
           <a:prstGeom prst="rect">
             <a:avLst/>
@@ -12800,7 +11867,7 @@
         </p:nvSpPr>
         <p:spPr>
           <a:xfrm>
-            <a:off x="9256514" y="2289125"/>
+            <a:off x="9256514" y="2436763"/>
             <a:ext cx="2012655" cy="720030"/>
           </a:xfrm>
           <a:prstGeom prst="rect">
@@ -12842,7 +11909,7 @@
         </p:nvSpPr>
         <p:spPr>
           <a:xfrm>
-            <a:off x="9256514" y="3136850"/>
+            <a:off x="9256514" y="3316858"/>
             <a:ext cx="2012655" cy="477738"/>
           </a:xfrm>
           <a:prstGeom prst="rect">
@@ -12927,7 +11994,7 @@
         <p:spPr>
           <a:xfrm>
             <a:off x="685800" y="6450360"/>
-            <a:ext cx="617007" cy="148530"/>
+            <a:ext cx="1675790" cy="148530"/>
           </a:xfrm>
           <a:prstGeom prst="rect">
             <a:avLst/>
@@ -12954,7 +12021,7 @@
                 <a:ea typeface="Inter" pitchFamily="34" charset="-122"/>
                 <a:cs typeface="Inter" pitchFamily="34" charset="-120"/>
               </a:rPr>
-              <a:t>Deckwerk</a:t>
+              <a:t>Geprüft, bevor du es siehst</a:t>
             </a:r>
             <a:endParaRPr lang="de-DE" sz="975" dirty="0"/>
           </a:p>
@@ -12968,8 +12035,8 @@
         </p:nvSpPr>
         <p:spPr>
           <a:xfrm>
-            <a:off x="11426875" y="6450360"/>
-            <a:ext cx="80515" cy="148530"/>
+            <a:off x="11174388" y="6450360"/>
+            <a:ext cx="336789" cy="148530"/>
           </a:xfrm>
           <a:prstGeom prst="rect">
             <a:avLst/>
@@ -12996,7 +12063,7 @@
                 <a:ea typeface="Inter" pitchFamily="34" charset="-122"/>
                 <a:cs typeface="Inter" pitchFamily="34" charset="-120"/>
               </a:rPr>
-              <a:t>9</a:t>
+              <a:t>9 / 12</a:t>
             </a:r>
             <a:endParaRPr lang="de-DE" sz="975" dirty="0"/>
           </a:p>

</xml_diff>